<commit_message>
P0 적용: AIRD 표준 MMI(v0.87), 불변 Dataset URI, 벌크 정본, 재현성 보강
외부 구현 검토(P0 7건) 반영:
- aird-mmi-v1.1: AIRD 제2부 v0.87 표준 MMI 4지표(D5-03 통계적 타당성,
  D6-01 유일성, D7-01 인코딩 일관성, D7-02 기술적 유효성)로 교체.
  QI_MMI 0.9999 → 'DM-0 (기본 적합성, STRUCT, 참고)' — 참고 공시,
  aird:qualityTier는 Discoverable에서 기록 금지(제3부 5.3절).
  기존 8지표는 catalog-discoverability-v1.0(참고)으로 이관, v1.0 규칙 폐기 표기
- Dataset 정본 URI를 목록키 기반 불변으로 수정(/dataset/{목록키}),
  record_id는 내부 식별자(kdp:recordId), FILE/API 이중 등재는 동일 데이터셋의
  복수 제공 형태로 해석(CatalogRecord가 유형 구분)
- 벌크 정본 산출: datasets/catalog-records/quality-annotations NDJSON+gzip,
  aird-assessment-{월}.jsonld(측정 해시·도구·규칙 provenance 포함)
- 이슈 관찰 DQV·PROV JSON-LD 표현(dqv:QualityAnnotation + prov:wasGeneratedBy)
- 재현성: fixture 빌드 테스트(실카탈로그 없이 전 과정 검증), requirements.lock,
  CORS·rate limit 환경변수화(DATANAV_CORS_ORIGINS 등)
- README 상태 정의('v1.0 코어 구현 후보 M1·M2 beta'), PPT 문구 정정
- 테스트 28개 통과, 2026-02 재빌드·무중단 전환 확인

Co-Authored-By: Claude Fable 5 <noreply@anthropic.com>
</commit_message>
<xml_diff>
--- a/docs/공공데이터_내비게이터_구현정리_v1.0.pptx
+++ b/docs/공공데이터_내비게이터_구현정리_v1.0.pptx
@@ -512,7 +512,7 @@
           <a:p>
             <a:r>
               <a:rPr lang="en-US" dirty="0"/>
-              <a:t>설계서 v1.0 확정판(동결) 기반. 기존 구현은 백업 후 삭제, M1(1층 정본+MCP)과 M2(웹 비생성형)를 재구현.</a:t>
+              <a:t>설계서 v1.0 확정판(동결) 기반. AIRD 진단은 제2부 v0.87 표준 MMI(D5-03·D6-01·D7-01·D7-02) 기준이며 DM-0은 참고 공시. 벌크 정본(datasets/catalog-records/quality-annotations NDJSON) 산출.</a:t>
             </a:r>
             <a:endParaRPr lang="en-US" dirty="0"/>
           </a:p>
@@ -1876,7 +1876,7 @@
                 <a:ea typeface="Arial" pitchFamily="34" charset="-122"/>
                 <a:cs typeface="Arial" pitchFamily="34" charset="-120"/>
               </a:rPr>
-              <a:t>설계서 v1.0 확정판 기반 M1 + M2 재구현  ·  스냅샷 2026-02  ·  2026-07-17</a:t>
+              <a:t>설계서 v1.0 확정판 기반 M1 + M2 — 코어 구현 후보(beta)  ·  스냅샷 2026-02  ·  2026-07-17</a:t>
             </a:r>
             <a:endParaRPr lang="en-US" sz="1300" dirty="0"/>
           </a:p>
@@ -2137,7 +2137,7 @@
                 <a:ea typeface="Arial" pitchFamily="34" charset="-122"/>
                 <a:cs typeface="Arial" pitchFamily="34" charset="-120"/>
               </a:rPr>
-              <a:t>DM-0</a:t>
+              <a:t>DM-0 (참고)</a:t>
             </a:r>
             <a:endParaRPr lang="en-US" sz="2100" dirty="0"/>
           </a:p>
@@ -2176,7 +2176,7 @@
                 <a:ea typeface="Arial" pitchFamily="34" charset="-122"/>
                 <a:cs typeface="Arial" pitchFamily="34" charset="-120"/>
               </a:rPr>
-              <a:t>AIRD 자가 진단</a:t>
+              <a:t>AIRD 표준 MMI 진단</a:t>
             </a:r>
             <a:endParaRPr lang="en-US" sz="1050" dirty="0"/>
           </a:p>
@@ -6119,7 +6119,7 @@
                 <a:ea typeface="Arial" pitchFamily="34" charset="-122"/>
                 <a:cs typeface="Arial" pitchFamily="34" charset="-120"/>
               </a:rPr>
-              <a:t>0.9996</a:t>
+              <a:t>0.9999</a:t>
             </a:r>
             <a:endParaRPr lang="en-US" sz="3000" dirty="0"/>
           </a:p>
@@ -6158,7 +6158,7 @@
                 <a:ea typeface="Arial" pitchFamily="34" charset="-122"/>
                 <a:cs typeface="Arial" pitchFamily="34" charset="-120"/>
               </a:rPr>
-              <a:t>QI_MMI → DM-0 부여</a:t>
+              <a:t>QI_MMI → DM-0 (참고)</a:t>
             </a:r>
             <a:endParaRPr lang="en-US" sz="1150" dirty="0"/>
           </a:p>
@@ -6200,7 +6200,7 @@
                 <a:ea typeface="Arial" pitchFamily="34" charset="-122"/>
                 <a:cs typeface="Arial" pitchFamily="34" charset="-120"/>
               </a:rPr>
-              <a:t>MMI 8지표 전수 측정, 임계 0.7 (aird-mmi-v1.0)</a:t>
+              <a:t>표준 MMI 4지표 D5-03·D6-01·D7-01·D7-02, 임계 0.7 (aird-mmi-v1.1)</a:t>
             </a:r>
             <a:endParaRPr lang="en-US" sz="950" dirty="0"/>
           </a:p>
@@ -6427,7 +6427,7 @@
                 <a:ea typeface="Arial" pitchFamily="34" charset="-122"/>
                 <a:cs typeface="Arial" pitchFamily="34" charset="-120"/>
               </a:rPr>
-              <a:t>14종</a:t>
+              <a:t>16종</a:t>
             </a:r>
             <a:endParaRPr lang="en-US" sz="3000" dirty="0"/>
           </a:p>

</xml_diff>